<commit_message>
closing summary slide: contributions and findings, as the last main page
New slide after References (trackb p.27, deck now 34 pages): a two-column
summary -- 'Built & verified' (five tracks, Track B completion, the baselines
including our loss, the AQC crossover, the 54-row ledger) and 'Found & learned'
(the phase trap and its three sightings, the pre-registered hardware
falsification with the visibility threshold, the free error bar, the DOS link,
the SKQD boundary). Every line tagged. Closing line: 'real wins and real
negatives, every number sourced -- that is the contribution.' Positioned as the
leave-up slide for Q&A, and script block M5 ends by saying so.

Caught before commit: the draft said '55-row ledger'; RESULTS has 54 rows.
First render overflowed 29pt; tightened to scriptsize with two bullets
shortened, now sub-visual.

slides_content gains the S16b entry (owner M5), script M5 closing lines
updated, trackb.pptx rebuilt (34 slides) and the two doc PDFs re-rendered.
</commit_message>
<xml_diff>
--- a/delivery/slides/trackb.pptx
+++ b/delivery/slides/trackb.pptx
@@ -38,6 +38,7 @@
     <p:sldId id="286" r:id="rId37"/>
     <p:sldId id="287" r:id="rId38"/>
     <p:sldId id="288" r:id="rId39"/>
+    <p:sldId id="289" r:id="rId40"/>
   </p:sldIdLst>
   <p:sldSz cx="12191695" cy="6858000" type="screen4x3"/>
   <p:notesSz cx="6858000" cy="9144000"/>
@@ -4215,6 +4216,48 @@
       <p:pic>
         <p:nvPicPr>
           <p:cNvPr id="2" name="Picture 1" descr="p-33.png"/>
+          <p:cNvPicPr>
+            <a:picLocks noChangeAspect="1"/>
+          </p:cNvPicPr>
+          <p:nvPr/>
+        </p:nvPicPr>
+        <p:blipFill>
+          <a:blip r:embed="rId2"/>
+          <a:stretch>
+            <a:fillRect/>
+          </a:stretch>
+        </p:blipFill>
+        <p:spPr>
+          <a:xfrm>
+            <a:off x="0" y="0"/>
+            <a:ext cx="12191695" cy="6858000"/>
+          </a:xfrm>
+          <a:prstGeom prst="rect">
+            <a:avLst/>
+          </a:prstGeom>
+        </p:spPr>
+      </p:pic>
+    </p:spTree>
+  </p:cSld>
+  <p:clrMapOvr>
+    <a:masterClrMapping/>
+  </p:clrMapOvr>
+</p:sld>
+</file>
+
+<file path=ppt/slides/slide34.xml><?xml version="1.0" encoding="utf-8"?>
+<p:sld xmlns:a="http://schemas.openxmlformats.org/drawingml/2006/main" xmlns:p="http://schemas.openxmlformats.org/presentationml/2006/main" xmlns:r="http://schemas.openxmlformats.org/officeDocument/2006/relationships">
+  <p:cSld>
+    <p:spTree>
+      <p:nvGrpSpPr>
+        <p:cNvPr id="1" name=""/>
+        <p:cNvGrpSpPr/>
+        <p:nvPr/>
+      </p:nvGrpSpPr>
+      <p:grpSpPr/>
+      <p:pic>
+        <p:nvPicPr>
+          <p:cNvPr id="2" name="Picture 1" descr="p-34.png"/>
           <p:cNvPicPr>
             <a:picLocks noChangeAspect="1"/>
           </p:cNvPicPr>

</xml_diff>